<commit_message>
Adiciona apresentacao do Norte e faixa horaria data-driven
- Horas_Norte_Executivo.pptx + narrativa/dados do Norte (R7.2 AP/MA/PA/PI)
- build_horas: token {faixa_top}/{faixa_baixas} para a alavanca 2 se
  autoajustar a faixa de maior acionamento por regional (Norte=Noite, CE=Dia)
- build_horas: colchete "Sobreaviso" movido para baixo da barra (nao colide
  com o titulo quando o DSR e pequeno, como no Norte com 86% de sobreaviso)
- narrativa_ceara atualizada para usar o token da faixa; CE reconstruido

Co-Authored-By: Claude Opus 4.8 <noreply@anthropic.com>
</commit_message>
<xml_diff>
--- a/outputs/horas/Horas_Ceara_Executivo.pptx
+++ b/outputs/horas/Horas_Ceara_Executivo.pptx
@@ -5047,8 +5047,8 @@
         </p:nvSpPr>
         <p:spPr>
           <a:xfrm>
-            <a:off x="6286500" y="3105150"/>
-            <a:ext cx="2858292" cy="381000"/>
+            <a:off x="6286500" y="3048000"/>
+            <a:ext cx="2858292" cy="323850"/>
           </a:xfrm>
           <a:prstGeom prst="rect">
             <a:avLst/>
@@ -5091,8 +5091,8 @@
         </p:nvSpPr>
         <p:spPr>
           <a:xfrm>
-            <a:off x="9144792" y="3105150"/>
-            <a:ext cx="1413033" cy="381000"/>
+            <a:off x="9144792" y="3048000"/>
+            <a:ext cx="1413033" cy="323850"/>
           </a:xfrm>
           <a:prstGeom prst="rect">
             <a:avLst/>
@@ -5135,8 +5135,8 @@
         </p:nvSpPr>
         <p:spPr>
           <a:xfrm>
-            <a:off x="10557825" y="3105150"/>
-            <a:ext cx="762676" cy="381000"/>
+            <a:off x="10557825" y="3048000"/>
+            <a:ext cx="762676" cy="323850"/>
           </a:xfrm>
           <a:prstGeom prst="rect">
             <a:avLst/>
@@ -5179,8 +5179,8 @@
         </p:nvSpPr>
         <p:spPr>
           <a:xfrm>
-            <a:off x="11320501" y="3105150"/>
-            <a:ext cx="268091" cy="381000"/>
+            <a:off x="11320501" y="3048000"/>
+            <a:ext cx="268091" cy="323850"/>
           </a:xfrm>
           <a:prstGeom prst="rect">
             <a:avLst/>
@@ -5223,8 +5223,8 @@
         </p:nvSpPr>
         <p:spPr>
           <a:xfrm>
-            <a:off x="11588593" y="3105150"/>
-            <a:ext cx="50956" cy="381000"/>
+            <a:off x="11588593" y="3048000"/>
+            <a:ext cx="50956" cy="323850"/>
           </a:xfrm>
           <a:prstGeom prst="rect">
             <a:avLst/>
@@ -5267,7 +5267,7 @@
         </p:nvSpPr>
         <p:spPr>
           <a:xfrm>
-            <a:off x="9144792" y="3048000"/>
+            <a:off x="9144792" y="3409950"/>
             <a:ext cx="2175709" cy="28575"/>
           </a:xfrm>
           <a:prstGeom prst="rect">
@@ -5311,7 +5311,7 @@
         </p:nvSpPr>
         <p:spPr>
           <a:xfrm>
-            <a:off x="9144792" y="2857500"/>
+            <a:off x="9144792" y="3448050"/>
             <a:ext cx="2175709" cy="152400"/>
           </a:xfrm>
           <a:prstGeom prst="rect">
@@ -5325,7 +5325,7 @@
           </a:bodyPr>
           <a:lstStyle/>
           <a:p>
-            <a:pPr algn="l">
+            <a:pPr algn="ctr">
               <a:lnSpc>
                 <a:spcPct val="106000"/>
               </a:lnSpc>
@@ -5350,7 +5350,7 @@
         </p:nvSpPr>
         <p:spPr>
           <a:xfrm>
-            <a:off x="6286500" y="3676650"/>
+            <a:off x="6286500" y="3714750"/>
             <a:ext cx="114300" cy="114300"/>
           </a:xfrm>
           <a:prstGeom prst="rect">
@@ -5394,7 +5394,7 @@
         </p:nvSpPr>
         <p:spPr>
           <a:xfrm>
-            <a:off x="6477000" y="3657600"/>
+            <a:off x="6477000" y="3695700"/>
             <a:ext cx="2857500" cy="152400"/>
           </a:xfrm>
           <a:prstGeom prst="rect">
@@ -5433,7 +5433,7 @@
         </p:nvSpPr>
         <p:spPr>
           <a:xfrm>
-            <a:off x="6477000" y="3657600"/>
+            <a:off x="6477000" y="3695700"/>
             <a:ext cx="5257800" cy="152400"/>
           </a:xfrm>
           <a:prstGeom prst="rect">
@@ -5472,7 +5472,7 @@
         </p:nvSpPr>
         <p:spPr>
           <a:xfrm>
-            <a:off x="6286500" y="3886200"/>
+            <a:off x="6286500" y="3924300"/>
             <a:ext cx="114300" cy="114300"/>
           </a:xfrm>
           <a:prstGeom prst="rect">
@@ -5516,7 +5516,7 @@
         </p:nvSpPr>
         <p:spPr>
           <a:xfrm>
-            <a:off x="6477000" y="3867150"/>
+            <a:off x="6477000" y="3905250"/>
             <a:ext cx="2857500" cy="152400"/>
           </a:xfrm>
           <a:prstGeom prst="rect">
@@ -5555,7 +5555,7 @@
         </p:nvSpPr>
         <p:spPr>
           <a:xfrm>
-            <a:off x="6477000" y="3867150"/>
+            <a:off x="6477000" y="3905250"/>
             <a:ext cx="5257800" cy="152400"/>
           </a:xfrm>
           <a:prstGeom prst="rect">
@@ -5594,7 +5594,7 @@
         </p:nvSpPr>
         <p:spPr>
           <a:xfrm>
-            <a:off x="6286500" y="4095750"/>
+            <a:off x="6286500" y="4133850"/>
             <a:ext cx="114300" cy="114300"/>
           </a:xfrm>
           <a:prstGeom prst="rect">
@@ -5638,7 +5638,7 @@
         </p:nvSpPr>
         <p:spPr>
           <a:xfrm>
-            <a:off x="6477000" y="4076700"/>
+            <a:off x="6477000" y="4114800"/>
             <a:ext cx="2857500" cy="152400"/>
           </a:xfrm>
           <a:prstGeom prst="rect">
@@ -5677,7 +5677,7 @@
         </p:nvSpPr>
         <p:spPr>
           <a:xfrm>
-            <a:off x="6477000" y="4076700"/>
+            <a:off x="6477000" y="4114800"/>
             <a:ext cx="5257800" cy="152400"/>
           </a:xfrm>
           <a:prstGeom prst="rect">
@@ -5716,7 +5716,7 @@
         </p:nvSpPr>
         <p:spPr>
           <a:xfrm>
-            <a:off x="6286500" y="4305300"/>
+            <a:off x="6286500" y="4343400"/>
             <a:ext cx="114300" cy="114300"/>
           </a:xfrm>
           <a:prstGeom prst="rect">
@@ -5760,7 +5760,7 @@
         </p:nvSpPr>
         <p:spPr>
           <a:xfrm>
-            <a:off x="6477000" y="4286250"/>
+            <a:off x="6477000" y="4324350"/>
             <a:ext cx="2857500" cy="152400"/>
           </a:xfrm>
           <a:prstGeom prst="rect">
@@ -5799,7 +5799,7 @@
         </p:nvSpPr>
         <p:spPr>
           <a:xfrm>
-            <a:off x="6477000" y="4286250"/>
+            <a:off x="6477000" y="4324350"/>
             <a:ext cx="5257800" cy="152400"/>
           </a:xfrm>
           <a:prstGeom prst="rect">
@@ -5838,7 +5838,7 @@
         </p:nvSpPr>
         <p:spPr>
           <a:xfrm>
-            <a:off x="6286500" y="4514850"/>
+            <a:off x="6286500" y="4552950"/>
             <a:ext cx="114300" cy="114300"/>
           </a:xfrm>
           <a:prstGeom prst="rect">
@@ -5882,7 +5882,7 @@
         </p:nvSpPr>
         <p:spPr>
           <a:xfrm>
-            <a:off x="6477000" y="4495800"/>
+            <a:off x="6477000" y="4533900"/>
             <a:ext cx="2857500" cy="152400"/>
           </a:xfrm>
           <a:prstGeom prst="rect">
@@ -5921,7 +5921,7 @@
         </p:nvSpPr>
         <p:spPr>
           <a:xfrm>
-            <a:off x="6477000" y="4495800"/>
+            <a:off x="6477000" y="4533900"/>
             <a:ext cx="5257800" cy="152400"/>
           </a:xfrm>
           <a:prstGeom prst="rect">
@@ -12514,7 +12514,7 @@
                 </a:solidFill>
                 <a:latin typeface="Aptos"/>
               </a:rPr>
-              <a:t>O acionamento se concentra na faixa Dia. Enxugar plantão nas faixas de menor acionamento (madrugada/tarde) e manter cobertura só onde a demanda real justifica.</a:t>
+              <a:t>O acionamento se concentra na faixa Dia (38%). Enxugar plantão nas faixas de menor acionamento (madrugada e tarde) e manter cobertura só onde a demanda real justifica.</a:t>
             </a:r>
           </a:p>
         </p:txBody>

</xml_diff>

<commit_message>
Adiciona apresentacoes MG/CO/SP e Nordeste; corrige overflow no slide 3
- Horas_Mgcosp_Executivo.pptx: R5 MG/SP INT/DF/GO/TO. GA Luis Carlos aciona
  25/25 dias e concentra sozinha ~44% do custo de sobreaviso (R$26,9 mil/mes);
  economia estimada de R$20,1 mil/mes convertendo para turno fixo.
- Horas_Nordeste_Executivo.pptx: R7.1 AL/BA/PB/PE/SE/RN. Custo pulverizado
  entre 6 GAs (top3 concentra so 61%, vs 75-89% nas demais regionais) -
  narrativa ajustada para corte distribuido em vez de mirar 1 area.
- build_horas: caixa "CONCENTRACAO" do slide 3 alargada (150->172px) e texto
  do callout reduzido (11->10.5pt) apos overflow com textos mais longos da
  narrativa do Nordeste; tabela realinhada para 340px.

Co-Authored-By: Claude Sonnet 5 <noreply@anthropic.com>
</commit_message>
<xml_diff>
--- a/outputs/horas/Horas_Ceara_Executivo.pptx
+++ b/outputs/horas/Horas_Ceara_Executivo.pptx
@@ -10986,7 +10986,7 @@
         <p:spPr>
           <a:xfrm>
             <a:off x="6667500" y="1428750"/>
-            <a:ext cx="4972050" cy="1428750"/>
+            <a:ext cx="4972050" cy="1638300"/>
           </a:xfrm>
           <a:prstGeom prst="roundRect">
             <a:avLst>
@@ -11031,7 +11031,7 @@
         </p:nvSpPr>
         <p:spPr>
           <a:xfrm>
-            <a:off x="6877050" y="1581150"/>
+            <a:off x="6877050" y="1562100"/>
             <a:ext cx="2857500" cy="133350"/>
           </a:xfrm>
           <a:prstGeom prst="rect">
@@ -11070,7 +11070,7 @@
         </p:nvSpPr>
         <p:spPr>
           <a:xfrm>
-            <a:off x="6877050" y="1771650"/>
+            <a:off x="6877050" y="1733550"/>
             <a:ext cx="1524000" cy="457200"/>
           </a:xfrm>
           <a:prstGeom prst="rect">
@@ -11090,7 +11090,7 @@
               </a:lnSpc>
             </a:pPr>
             <a:r>
-              <a:rPr sz="3800" b="1">
+              <a:rPr sz="3600" b="1">
                 <a:solidFill>
                   <a:srgbClr val="42DF4B"/>
                 </a:solidFill>
@@ -11109,8 +11109,8 @@
         </p:nvSpPr>
         <p:spPr>
           <a:xfrm>
-            <a:off x="6877050" y="2266950"/>
-            <a:ext cx="4572000" cy="533400"/>
+            <a:off x="6877050" y="2209800"/>
+            <a:ext cx="4572000" cy="781050"/>
           </a:xfrm>
           <a:prstGeom prst="rect">
             <a:avLst/>
@@ -11125,11 +11125,11 @@
           <a:p>
             <a:pPr algn="l">
               <a:lnSpc>
-                <a:spcPct val="106000"/>
+                <a:spcPct val="108000"/>
               </a:lnSpc>
             </a:pPr>
             <a:r>
-              <a:rPr sz="1100" b="0">
+              <a:rPr sz="1050" b="0">
                 <a:solidFill>
                   <a:srgbClr val="FFFFFF"/>
                 </a:solidFill>
@@ -11149,7 +11149,7 @@
           <p:nvPr/>
         </p:nvGraphicFramePr>
         <p:xfrm>
-          <a:off x="6667500" y="3048000"/>
+          <a:off x="6667500" y="3238500"/>
           <a:ext cx="4972050" cy="2857500"/>
         </p:xfrm>
         <a:graphic>

</xml_diff>